<commit_message>
Add PUT, PATCH, and DELETE to the Lecture 2 API lab.
Co-authored-by: Cursor <cursoragent@cursor.com>
</commit_message>
<xml_diff>
--- a/lec-02/presentation/lec-02-rest-apis.pptx
+++ b/lec-02/presentation/lec-02-rest-apis.pptx
@@ -140,21 +140,21 @@
   <p:extLst>
     <p:ext uri="{521415D9-36F7-43E2-AB2F-B90AF26B5E84}">
       <p14:sectionLst xmlns:p14="http://schemas.microsoft.com/office/powerpoint/2010/main">
-        <p14:section name="Welcome" id="{39e2af62-5c81-f673-8c16-56126cc1c025}">
+        <p14:section name="Welcome" id="{ae0e1125-c8bc-efc7-9946-aa9e10beb254}">
           <p14:sldIdLst>
             <p14:sldId id="256"/>
             <p14:sldId id="257"/>
             <p14:sldId id="258"/>
           </p14:sldIdLst>
         </p14:section>
-        <p14:section name="What an API is" id="{99704075-43e0-f748-b6ce-abcb6600a0ca}">
+        <p14:section name="What an API is" id="{505d93d9-47b4-65e3-d7f7-fa96b249bd14}">
           <p14:sldIdLst>
             <p14:sldId id="259"/>
             <p14:sldId id="260"/>
             <p14:sldId id="261"/>
           </p14:sldIdLst>
         </p14:section>
-        <p14:section name="HTTP" id="{1d61ee02-93f8-3fc0-8e53-041f7a7fe122}">
+        <p14:section name="HTTP" id="{edaac402-0ee4-65c8-f5c0-5fdbcc4b2294}">
           <p14:sldIdLst>
             <p14:sldId id="262"/>
             <p14:sldId id="263"/>
@@ -163,7 +163,7 @@
             <p14:sldId id="266"/>
           </p14:sldIdLst>
         </p14:section>
-        <p14:section name="Methods and status" id="{d59f71d2-deb9-91b6-c892-5874a81b92ce}">
+        <p14:section name="Methods and status" id="{0c05e1ea-eab7-f45e-1d16-2c48cdb91afe}">
           <p14:sldIdLst>
             <p14:sldId id="267"/>
             <p14:sldId id="268"/>
@@ -172,7 +172,7 @@
             <p14:sldId id="271"/>
           </p14:sldIdLst>
         </p14:section>
-        <p14:section name="Headers, JSON, auth" id="{b47aac06-2929-8723-cc91-a8934f4f0013}">
+        <p14:section name="Headers, JSON, auth" id="{eebc39d3-323a-6b5d-487e-12913c7c9dc9}">
           <p14:sldIdLst>
             <p14:sldId id="272"/>
             <p14:sldId id="273"/>
@@ -181,7 +181,7 @@
             <p14:sldId id="276"/>
           </p14:sldIdLst>
         </p14:section>
-        <p14:section name="How we call APIs" id="{7f1a5ce4-1617-7961-468a-abf20dec7901}">
+        <p14:section name="How we call APIs" id="{e58ba89c-9a1c-85cb-430a-4d7087361742}">
           <p14:sldIdLst>
             <p14:sldId id="277"/>
             <p14:sldId id="278"/>
@@ -190,7 +190,7 @@
             <p14:sldId id="281"/>
           </p14:sldIdLst>
         </p14:section>
-        <p14:section name="Lab" id="{c01e7737-fc5a-dad6-2ce6-c111f3d4416f}">
+        <p14:section name="Lab" id="{30ddad32-45c6-c487-fc13-9e4b1caa039b}">
           <p14:sldIdLst>
             <p14:sldId id="282"/>
             <p14:sldId id="283"/>
@@ -198,7 +198,7 @@
             <p14:sldId id="285"/>
           </p14:sldIdLst>
         </p14:section>
-        <p14:section name="Interview and close" id="{ecac8a1d-ab54-dc34-9978-3f327c21c248}">
+        <p14:section name="Interview and close" id="{f6631b98-56bd-9ed3-a7f6-6d6a38837a7f}">
           <p14:sldIdLst>
             <p14:sldId id="286"/>
             <p14:sldId id="287"/>
@@ -6913,7 +6913,7 @@
                           <a:ea typeface="Calibri" pitchFamily="34" charset="-122"/>
                           <a:cs typeface="Calibri" pitchFamily="34" charset="-120"/>
                         </a:rPr>
-                        <a:t>Not used in the lab</a:t>
+                        <a:t>PUT /notes/1</a:t>
                       </a:r>
                       <a:endParaRPr lang="en-US" sz="1400" dirty="0">
                         <a:latin typeface="Calibri" charset="0"/>
@@ -7103,7 +7103,7 @@
                           <a:ea typeface="Calibri" pitchFamily="34" charset="-122"/>
                           <a:cs typeface="Calibri" pitchFamily="34" charset="-120"/>
                         </a:rPr>
-                        <a:t>Not used in the lab</a:t>
+                        <a:t>PATCH /notes/2</a:t>
                       </a:r>
                       <a:endParaRPr lang="en-US" sz="1400" dirty="0">
                         <a:latin typeface="Calibri" charset="0"/>
@@ -7293,7 +7293,7 @@
                           <a:ea typeface="Calibri" pitchFamily="34" charset="-122"/>
                           <a:cs typeface="Calibri" pitchFamily="34" charset="-120"/>
                         </a:rPr>
-                        <a:t>Not used in the lab</a:t>
+                        <a:t>DELETE /notes/1</a:t>
                       </a:r>
                       <a:endParaRPr lang="en-US" sz="1400" dirty="0">
                         <a:latin typeface="Calibri" charset="0"/>
@@ -17758,6 +17758,386 @@
                           <a:ea typeface="Calibri" pitchFamily="34" charset="-122"/>
                           <a:cs typeface="Calibri" pitchFamily="34" charset="-120"/>
                         </a:rPr>
+                        <a:t>PUT / PATCH</a:t>
+                      </a:r>
+                      <a:endParaRPr lang="en-US" sz="1400" dirty="0">
+                        <a:latin typeface="Calibri" charset="0"/>
+                        <a:ea typeface="Calibri" charset="0"/>
+                        <a:cs typeface="Calibri" charset="0"/>
+                      </a:endParaRPr>
+                    </a:p>
+                  </a:txBody>
+                  <a:tcPr marL="91440" marR="91440" marT="45720" marB="45720" anchor="ctr">
+                    <a:lnL w="0" cap="flat" cmpd="sng" algn="ctr">
+                      <a:noFill/>
+                    </a:lnL>
+                    <a:lnR w="0" cap="flat" cmpd="sng" algn="ctr">
+                      <a:noFill/>
+                    </a:lnR>
+                    <a:lnT w="6350" cap="flat" cmpd="sng" algn="ctr">
+                      <a:solidFill>
+                        <a:srgbClr val="E2E8F0"/>
+                      </a:solidFill>
+                      <a:prstDash val="solid"/>
+                      <a:round/>
+                      <a:headEnd type="none" w="med" len="med"/>
+                      <a:tailEnd type="none" w="med" len="med"/>
+                    </a:lnT>
+                    <a:lnB w="0" cap="flat" cmpd="sng" algn="ctr">
+                      <a:noFill/>
+                    </a:lnB>
+                  </a:tcPr>
+                </a:tc>
+                <a:tc>
+                  <a:txBody>
+                    <a:bodyPr/>
+                    <a:lstStyle/>
+                    <a:p>
+                      <a:pPr algn="l" indent="0" marL="0">
+                        <a:buNone/>
+                      </a:pPr>
+                      <a:r>
+                        <a:rPr lang="en-US" sz="1400" dirty="0">
+                          <a:solidFill>
+                            <a:srgbClr val="0F172A"/>
+                          </a:solidFill>
+                          <a:latin typeface="Calibri" pitchFamily="34" charset="0"/>
+                          <a:ea typeface="Calibri" pitchFamily="34" charset="-122"/>
+                          <a:cs typeface="Calibri" pitchFamily="34" charset="-120"/>
+                        </a:rPr>
+                        <a:t>/notes/1</a:t>
+                      </a:r>
+                      <a:endParaRPr lang="en-US" sz="1400" dirty="0">
+                        <a:latin typeface="Calibri" charset="0"/>
+                        <a:ea typeface="Calibri" charset="0"/>
+                        <a:cs typeface="Calibri" charset="0"/>
+                      </a:endParaRPr>
+                    </a:p>
+                  </a:txBody>
+                  <a:tcPr marL="91440" marR="91440" marT="45720" marB="45720" anchor="ctr">
+                    <a:lnL w="0" cap="flat" cmpd="sng" algn="ctr">
+                      <a:noFill/>
+                    </a:lnL>
+                    <a:lnR w="0" cap="flat" cmpd="sng" algn="ctr">
+                      <a:noFill/>
+                    </a:lnR>
+                    <a:lnT w="6350" cap="flat" cmpd="sng" algn="ctr">
+                      <a:solidFill>
+                        <a:srgbClr val="E2E8F0"/>
+                      </a:solidFill>
+                      <a:prstDash val="solid"/>
+                      <a:round/>
+                      <a:headEnd type="none" w="med" len="med"/>
+                      <a:tailEnd type="none" w="med" len="med"/>
+                    </a:lnT>
+                    <a:lnB w="0" cap="flat" cmpd="sng" algn="ctr">
+                      <a:noFill/>
+                    </a:lnB>
+                  </a:tcPr>
+                </a:tc>
+                <a:tc>
+                  <a:txBody>
+                    <a:bodyPr/>
+                    <a:lstStyle/>
+                    <a:p>
+                      <a:pPr algn="l" indent="0" marL="0">
+                        <a:buNone/>
+                      </a:pPr>
+                      <a:r>
+                        <a:rPr lang="en-US" sz="1400" dirty="0">
+                          <a:solidFill>
+                            <a:srgbClr val="0F172A"/>
+                          </a:solidFill>
+                          <a:latin typeface="Calibri" pitchFamily="34" charset="0"/>
+                          <a:ea typeface="Calibri" pitchFamily="34" charset="-122"/>
+                          <a:cs typeface="Calibri" pitchFamily="34" charset="-120"/>
+                        </a:rPr>
+                        <a:t>200 updated note</a:t>
+                      </a:r>
+                      <a:endParaRPr lang="en-US" sz="1400" dirty="0">
+                        <a:latin typeface="Calibri" charset="0"/>
+                        <a:ea typeface="Calibri" charset="0"/>
+                        <a:cs typeface="Calibri" charset="0"/>
+                      </a:endParaRPr>
+                    </a:p>
+                  </a:txBody>
+                  <a:tcPr marL="91440" marR="91440" marT="45720" marB="45720" anchor="ctr">
+                    <a:lnL w="0" cap="flat" cmpd="sng" algn="ctr">
+                      <a:noFill/>
+                    </a:lnL>
+                    <a:lnR w="0" cap="flat" cmpd="sng" algn="ctr">
+                      <a:noFill/>
+                    </a:lnR>
+                    <a:lnT w="6350" cap="flat" cmpd="sng" algn="ctr">
+                      <a:solidFill>
+                        <a:srgbClr val="E2E8F0"/>
+                      </a:solidFill>
+                      <a:prstDash val="solid"/>
+                      <a:round/>
+                      <a:headEnd type="none" w="med" len="med"/>
+                      <a:tailEnd type="none" w="med" len="med"/>
+                    </a:lnT>
+                    <a:lnB w="0" cap="flat" cmpd="sng" algn="ctr">
+                      <a:noFill/>
+                    </a:lnB>
+                  </a:tcPr>
+                </a:tc>
+                <a:tc>
+                  <a:txBody>
+                    <a:bodyPr/>
+                    <a:lstStyle/>
+                    <a:p>
+                      <a:pPr algn="l" indent="0" marL="0">
+                        <a:buNone/>
+                      </a:pPr>
+                      <a:r>
+                        <a:rPr lang="en-US" sz="1400" dirty="0">
+                          <a:solidFill>
+                            <a:srgbClr val="0F172A"/>
+                          </a:solidFill>
+                          <a:latin typeface="Calibri" pitchFamily="34" charset="0"/>
+                          <a:ea typeface="Calibri" pitchFamily="34" charset="-122"/>
+                          <a:cs typeface="Calibri" pitchFamily="34" charset="-120"/>
+                        </a:rPr>
+                        <a:t>None</a:t>
+                      </a:r>
+                      <a:endParaRPr lang="en-US" sz="1400" dirty="0">
+                        <a:latin typeface="Calibri" charset="0"/>
+                        <a:ea typeface="Calibri" charset="0"/>
+                        <a:cs typeface="Calibri" charset="0"/>
+                      </a:endParaRPr>
+                    </a:p>
+                  </a:txBody>
+                  <a:tcPr marL="91440" marR="91440" marT="45720" marB="45720" anchor="ctr">
+                    <a:lnL w="0" cap="flat" cmpd="sng" algn="ctr">
+                      <a:noFill/>
+                    </a:lnL>
+                    <a:lnR w="0" cap="flat" cmpd="sng" algn="ctr">
+                      <a:noFill/>
+                    </a:lnR>
+                    <a:lnT w="6350" cap="flat" cmpd="sng" algn="ctr">
+                      <a:solidFill>
+                        <a:srgbClr val="E2E8F0"/>
+                      </a:solidFill>
+                      <a:prstDash val="solid"/>
+                      <a:round/>
+                      <a:headEnd type="none" w="med" len="med"/>
+                      <a:tailEnd type="none" w="med" len="med"/>
+                    </a:lnT>
+                    <a:lnB w="0" cap="flat" cmpd="sng" algn="ctr">
+                      <a:noFill/>
+                    </a:lnB>
+                  </a:tcPr>
+                </a:tc>
+              </a:tr>
+              <a:tr h="0">
+                <a:tc>
+                  <a:txBody>
+                    <a:bodyPr/>
+                    <a:lstStyle/>
+                    <a:p>
+                      <a:pPr algn="l" indent="0" marL="0">
+                        <a:buNone/>
+                      </a:pPr>
+                      <a:r>
+                        <a:rPr lang="en-US" sz="1400" dirty="0">
+                          <a:solidFill>
+                            <a:srgbClr val="0F172A"/>
+                          </a:solidFill>
+                          <a:latin typeface="Calibri" pitchFamily="34" charset="0"/>
+                          <a:ea typeface="Calibri" pitchFamily="34" charset="-122"/>
+                          <a:cs typeface="Calibri" pitchFamily="34" charset="-120"/>
+                        </a:rPr>
+                        <a:t>DELETE</a:t>
+                      </a:r>
+                      <a:endParaRPr lang="en-US" sz="1400" dirty="0">
+                        <a:latin typeface="Calibri" charset="0"/>
+                        <a:ea typeface="Calibri" charset="0"/>
+                        <a:cs typeface="Calibri" charset="0"/>
+                      </a:endParaRPr>
+                    </a:p>
+                  </a:txBody>
+                  <a:tcPr marL="91440" marR="91440" marT="45720" marB="45720" anchor="ctr">
+                    <a:lnL w="0" cap="flat" cmpd="sng" algn="ctr">
+                      <a:noFill/>
+                    </a:lnL>
+                    <a:lnR w="0" cap="flat" cmpd="sng" algn="ctr">
+                      <a:noFill/>
+                    </a:lnR>
+                    <a:lnT w="6350" cap="flat" cmpd="sng" algn="ctr">
+                      <a:solidFill>
+                        <a:srgbClr val="E2E8F0"/>
+                      </a:solidFill>
+                      <a:prstDash val="solid"/>
+                      <a:round/>
+                      <a:headEnd type="none" w="med" len="med"/>
+                      <a:tailEnd type="none" w="med" len="med"/>
+                    </a:lnT>
+                    <a:lnB w="0" cap="flat" cmpd="sng" algn="ctr">
+                      <a:noFill/>
+                    </a:lnB>
+                  </a:tcPr>
+                </a:tc>
+                <a:tc>
+                  <a:txBody>
+                    <a:bodyPr/>
+                    <a:lstStyle/>
+                    <a:p>
+                      <a:pPr algn="l" indent="0" marL="0">
+                        <a:buNone/>
+                      </a:pPr>
+                      <a:r>
+                        <a:rPr lang="en-US" sz="1400" dirty="0">
+                          <a:solidFill>
+                            <a:srgbClr val="0F172A"/>
+                          </a:solidFill>
+                          <a:latin typeface="Calibri" pitchFamily="34" charset="0"/>
+                          <a:ea typeface="Calibri" pitchFamily="34" charset="-122"/>
+                          <a:cs typeface="Calibri" pitchFamily="34" charset="-120"/>
+                        </a:rPr>
+                        <a:t>/notes/1</a:t>
+                      </a:r>
+                      <a:endParaRPr lang="en-US" sz="1400" dirty="0">
+                        <a:latin typeface="Calibri" charset="0"/>
+                        <a:ea typeface="Calibri" charset="0"/>
+                        <a:cs typeface="Calibri" charset="0"/>
+                      </a:endParaRPr>
+                    </a:p>
+                  </a:txBody>
+                  <a:tcPr marL="91440" marR="91440" marT="45720" marB="45720" anchor="ctr">
+                    <a:lnL w="0" cap="flat" cmpd="sng" algn="ctr">
+                      <a:noFill/>
+                    </a:lnL>
+                    <a:lnR w="0" cap="flat" cmpd="sng" algn="ctr">
+                      <a:noFill/>
+                    </a:lnR>
+                    <a:lnT w="6350" cap="flat" cmpd="sng" algn="ctr">
+                      <a:solidFill>
+                        <a:srgbClr val="E2E8F0"/>
+                      </a:solidFill>
+                      <a:prstDash val="solid"/>
+                      <a:round/>
+                      <a:headEnd type="none" w="med" len="med"/>
+                      <a:tailEnd type="none" w="med" len="med"/>
+                    </a:lnT>
+                    <a:lnB w="0" cap="flat" cmpd="sng" algn="ctr">
+                      <a:noFill/>
+                    </a:lnB>
+                  </a:tcPr>
+                </a:tc>
+                <a:tc>
+                  <a:txBody>
+                    <a:bodyPr/>
+                    <a:lstStyle/>
+                    <a:p>
+                      <a:pPr algn="l" indent="0" marL="0">
+                        <a:buNone/>
+                      </a:pPr>
+                      <a:r>
+                        <a:rPr lang="en-US" sz="1400" dirty="0">
+                          <a:solidFill>
+                            <a:srgbClr val="0F172A"/>
+                          </a:solidFill>
+                          <a:latin typeface="Calibri" pitchFamily="34" charset="0"/>
+                          <a:ea typeface="Calibri" pitchFamily="34" charset="-122"/>
+                          <a:cs typeface="Calibri" pitchFamily="34" charset="-120"/>
+                        </a:rPr>
+                        <a:t>200 {"deleted":1}</a:t>
+                      </a:r>
+                      <a:endParaRPr lang="en-US" sz="1400" dirty="0">
+                        <a:latin typeface="Calibri" charset="0"/>
+                        <a:ea typeface="Calibri" charset="0"/>
+                        <a:cs typeface="Calibri" charset="0"/>
+                      </a:endParaRPr>
+                    </a:p>
+                  </a:txBody>
+                  <a:tcPr marL="91440" marR="91440" marT="45720" marB="45720" anchor="ctr">
+                    <a:lnL w="0" cap="flat" cmpd="sng" algn="ctr">
+                      <a:noFill/>
+                    </a:lnL>
+                    <a:lnR w="0" cap="flat" cmpd="sng" algn="ctr">
+                      <a:noFill/>
+                    </a:lnR>
+                    <a:lnT w="6350" cap="flat" cmpd="sng" algn="ctr">
+                      <a:solidFill>
+                        <a:srgbClr val="E2E8F0"/>
+                      </a:solidFill>
+                      <a:prstDash val="solid"/>
+                      <a:round/>
+                      <a:headEnd type="none" w="med" len="med"/>
+                      <a:tailEnd type="none" w="med" len="med"/>
+                    </a:lnT>
+                    <a:lnB w="0" cap="flat" cmpd="sng" algn="ctr">
+                      <a:noFill/>
+                    </a:lnB>
+                  </a:tcPr>
+                </a:tc>
+                <a:tc>
+                  <a:txBody>
+                    <a:bodyPr/>
+                    <a:lstStyle/>
+                    <a:p>
+                      <a:pPr algn="l" indent="0" marL="0">
+                        <a:buNone/>
+                      </a:pPr>
+                      <a:r>
+                        <a:rPr lang="en-US" sz="1400" dirty="0">
+                          <a:solidFill>
+                            <a:srgbClr val="0F172A"/>
+                          </a:solidFill>
+                          <a:latin typeface="Calibri" pitchFamily="34" charset="0"/>
+                          <a:ea typeface="Calibri" pitchFamily="34" charset="-122"/>
+                          <a:cs typeface="Calibri" pitchFamily="34" charset="-120"/>
+                        </a:rPr>
+                        <a:t>None</a:t>
+                      </a:r>
+                      <a:endParaRPr lang="en-US" sz="1400" dirty="0">
+                        <a:latin typeface="Calibri" charset="0"/>
+                        <a:ea typeface="Calibri" charset="0"/>
+                        <a:cs typeface="Calibri" charset="0"/>
+                      </a:endParaRPr>
+                    </a:p>
+                  </a:txBody>
+                  <a:tcPr marL="91440" marR="91440" marT="45720" marB="45720" anchor="ctr">
+                    <a:lnL w="0" cap="flat" cmpd="sng" algn="ctr">
+                      <a:noFill/>
+                    </a:lnL>
+                    <a:lnR w="0" cap="flat" cmpd="sng" algn="ctr">
+                      <a:noFill/>
+                    </a:lnR>
+                    <a:lnT w="6350" cap="flat" cmpd="sng" algn="ctr">
+                      <a:solidFill>
+                        <a:srgbClr val="E2E8F0"/>
+                      </a:solidFill>
+                      <a:prstDash val="solid"/>
+                      <a:round/>
+                      <a:headEnd type="none" w="med" len="med"/>
+                      <a:tailEnd type="none" w="med" len="med"/>
+                    </a:lnT>
+                    <a:lnB w="0" cap="flat" cmpd="sng" algn="ctr">
+                      <a:noFill/>
+                    </a:lnB>
+                  </a:tcPr>
+                </a:tc>
+              </a:tr>
+              <a:tr h="0">
+                <a:tc>
+                  <a:txBody>
+                    <a:bodyPr/>
+                    <a:lstStyle/>
+                    <a:p>
+                      <a:pPr algn="l" indent="0" marL="0">
+                        <a:buNone/>
+                      </a:pPr>
+                      <a:r>
+                        <a:rPr lang="en-US" sz="1400" dirty="0">
+                          <a:solidFill>
+                            <a:srgbClr val="0F172A"/>
+                          </a:solidFill>
+                          <a:latin typeface="Calibri" pitchFamily="34" charset="0"/>
+                          <a:ea typeface="Calibri" pitchFamily="34" charset="-122"/>
+                          <a:cs typeface="Calibri" pitchFamily="34" charset="-120"/>
+                        </a:rPr>
                         <a:t>GET</a:t>
                       </a:r>
                       <a:endParaRPr lang="en-US" sz="1400" dirty="0">
@@ -20051,6 +20431,435 @@
                           <a:cs typeface="Calibri" pitchFamily="34" charset="-120"/>
                         </a:rPr>
                         <a:t>201 and your text</a:t>
+                      </a:r>
+                      <a:endParaRPr lang="en-US" sz="1300" dirty="0">
+                        <a:latin typeface="Calibri" charset="0"/>
+                        <a:ea typeface="Calibri" charset="0"/>
+                        <a:cs typeface="Calibri" charset="0"/>
+                      </a:endParaRPr>
+                    </a:p>
+                  </a:txBody>
+                  <a:tcPr marL="91440" marR="91440" marT="45720" marB="45720" anchor="ctr">
+                    <a:lnL w="0" cap="flat" cmpd="sng" algn="ctr">
+                      <a:noFill/>
+                    </a:lnL>
+                    <a:lnR w="0" cap="flat" cmpd="sng" algn="ctr">
+                      <a:noFill/>
+                    </a:lnR>
+                    <a:lnT w="6350" cap="flat" cmpd="sng" algn="ctr">
+                      <a:solidFill>
+                        <a:srgbClr val="E2E8F0"/>
+                      </a:solidFill>
+                      <a:prstDash val="solid"/>
+                      <a:round/>
+                      <a:headEnd type="none" w="med" len="med"/>
+                      <a:tailEnd type="none" w="med" len="med"/>
+                    </a:lnT>
+                    <a:lnB w="0" cap="flat" cmpd="sng" algn="ctr">
+                      <a:noFill/>
+                    </a:lnB>
+                  </a:tcPr>
+                </a:tc>
+              </a:tr>
+              <a:tr h="0">
+                <a:tc>
+                  <a:txBody>
+                    <a:bodyPr/>
+                    <a:lstStyle/>
+                    <a:p>
+                      <a:pPr algn="l" indent="0" marL="0">
+                        <a:buNone/>
+                      </a:pPr>
+                      <a:r>
+                        <a:rPr lang="en-US" sz="1300" dirty="0">
+                          <a:solidFill>
+                            <a:srgbClr val="0F172A"/>
+                          </a:solidFill>
+                          <a:latin typeface="Calibri" pitchFamily="34" charset="0"/>
+                          <a:ea typeface="Calibri" pitchFamily="34" charset="-122"/>
+                          <a:cs typeface="Calibri" pitchFamily="34" charset="-120"/>
+                        </a:rPr>
+                        <a:t>Replace</a:t>
+                      </a:r>
+                      <a:endParaRPr lang="en-US" sz="1300" dirty="0">
+                        <a:latin typeface="Calibri" charset="0"/>
+                        <a:ea typeface="Calibri" charset="0"/>
+                        <a:cs typeface="Calibri" charset="0"/>
+                      </a:endParaRPr>
+                    </a:p>
+                  </a:txBody>
+                  <a:tcPr marL="91440" marR="91440" marT="45720" marB="45720" anchor="ctr">
+                    <a:lnL w="0" cap="flat" cmpd="sng" algn="ctr">
+                      <a:noFill/>
+                    </a:lnL>
+                    <a:lnR w="0" cap="flat" cmpd="sng" algn="ctr">
+                      <a:noFill/>
+                    </a:lnR>
+                    <a:lnT w="6350" cap="flat" cmpd="sng" algn="ctr">
+                      <a:solidFill>
+                        <a:srgbClr val="E2E8F0"/>
+                      </a:solidFill>
+                      <a:prstDash val="solid"/>
+                      <a:round/>
+                      <a:headEnd type="none" w="med" len="med"/>
+                      <a:tailEnd type="none" w="med" len="med"/>
+                    </a:lnT>
+                    <a:lnB w="0" cap="flat" cmpd="sng" algn="ctr">
+                      <a:noFill/>
+                    </a:lnB>
+                  </a:tcPr>
+                </a:tc>
+                <a:tc>
+                  <a:txBody>
+                    <a:bodyPr/>
+                    <a:lstStyle/>
+                    <a:p>
+                      <a:pPr algn="l" indent="0" marL="0">
+                        <a:buNone/>
+                      </a:pPr>
+                      <a:r>
+                        <a:rPr lang="en-US" sz="1300" dirty="0">
+                          <a:solidFill>
+                            <a:srgbClr val="0F172A"/>
+                          </a:solidFill>
+                          <a:latin typeface="Calibri" pitchFamily="34" charset="0"/>
+                          <a:ea typeface="Calibri" pitchFamily="34" charset="-122"/>
+                          <a:cs typeface="Calibri" pitchFamily="34" charset="-120"/>
+                        </a:rPr>
+                        <a:t>curl -X PUT .../notes/1 -d JSON</a:t>
+                      </a:r>
+                      <a:endParaRPr lang="en-US" sz="1300" dirty="0">
+                        <a:latin typeface="Calibri" charset="0"/>
+                        <a:ea typeface="Calibri" charset="0"/>
+                        <a:cs typeface="Calibri" charset="0"/>
+                      </a:endParaRPr>
+                    </a:p>
+                  </a:txBody>
+                  <a:tcPr marL="91440" marR="91440" marT="45720" marB="45720" anchor="ctr">
+                    <a:lnL w="0" cap="flat" cmpd="sng" algn="ctr">
+                      <a:noFill/>
+                    </a:lnL>
+                    <a:lnR w="0" cap="flat" cmpd="sng" algn="ctr">
+                      <a:noFill/>
+                    </a:lnR>
+                    <a:lnT w="6350" cap="flat" cmpd="sng" algn="ctr">
+                      <a:solidFill>
+                        <a:srgbClr val="E2E8F0"/>
+                      </a:solidFill>
+                      <a:prstDash val="solid"/>
+                      <a:round/>
+                      <a:headEnd type="none" w="med" len="med"/>
+                      <a:tailEnd type="none" w="med" len="med"/>
+                    </a:lnT>
+                    <a:lnB w="0" cap="flat" cmpd="sng" algn="ctr">
+                      <a:noFill/>
+                    </a:lnB>
+                  </a:tcPr>
+                </a:tc>
+                <a:tc>
+                  <a:txBody>
+                    <a:bodyPr/>
+                    <a:lstStyle/>
+                    <a:p>
+                      <a:pPr algn="l" indent="0" marL="0">
+                        <a:buNone/>
+                      </a:pPr>
+                      <a:r>
+                        <a:rPr lang="en-US" sz="1300" dirty="0">
+                          <a:solidFill>
+                            <a:srgbClr val="0F172A"/>
+                          </a:solidFill>
+                          <a:latin typeface="Calibri" pitchFamily="34" charset="0"/>
+                          <a:ea typeface="Calibri" pitchFamily="34" charset="-122"/>
+                          <a:cs typeface="Calibri" pitchFamily="34" charset="-120"/>
+                        </a:rPr>
+                        <a:t>200, text replaced</a:t>
+                      </a:r>
+                      <a:endParaRPr lang="en-US" sz="1300" dirty="0">
+                        <a:latin typeface="Calibri" charset="0"/>
+                        <a:ea typeface="Calibri" charset="0"/>
+                        <a:cs typeface="Calibri" charset="0"/>
+                      </a:endParaRPr>
+                    </a:p>
+                  </a:txBody>
+                  <a:tcPr marL="91440" marR="91440" marT="45720" marB="45720" anchor="ctr">
+                    <a:lnL w="0" cap="flat" cmpd="sng" algn="ctr">
+                      <a:noFill/>
+                    </a:lnL>
+                    <a:lnR w="0" cap="flat" cmpd="sng" algn="ctr">
+                      <a:noFill/>
+                    </a:lnR>
+                    <a:lnT w="6350" cap="flat" cmpd="sng" algn="ctr">
+                      <a:solidFill>
+                        <a:srgbClr val="E2E8F0"/>
+                      </a:solidFill>
+                      <a:prstDash val="solid"/>
+                      <a:round/>
+                      <a:headEnd type="none" w="med" len="med"/>
+                      <a:tailEnd type="none" w="med" len="med"/>
+                    </a:lnT>
+                    <a:lnB w="0" cap="flat" cmpd="sng" algn="ctr">
+                      <a:noFill/>
+                    </a:lnB>
+                  </a:tcPr>
+                </a:tc>
+              </a:tr>
+              <a:tr h="0">
+                <a:tc>
+                  <a:txBody>
+                    <a:bodyPr/>
+                    <a:lstStyle/>
+                    <a:p>
+                      <a:pPr algn="l" indent="0" marL="0">
+                        <a:buNone/>
+                      </a:pPr>
+                      <a:r>
+                        <a:rPr lang="en-US" sz="1300" dirty="0">
+                          <a:solidFill>
+                            <a:srgbClr val="0F172A"/>
+                          </a:solidFill>
+                          <a:latin typeface="Calibri" pitchFamily="34" charset="0"/>
+                          <a:ea typeface="Calibri" pitchFamily="34" charset="-122"/>
+                          <a:cs typeface="Calibri" pitchFamily="34" charset="-120"/>
+                        </a:rPr>
+                        <a:t>Patch</a:t>
+                      </a:r>
+                      <a:endParaRPr lang="en-US" sz="1300" dirty="0">
+                        <a:latin typeface="Calibri" charset="0"/>
+                        <a:ea typeface="Calibri" charset="0"/>
+                        <a:cs typeface="Calibri" charset="0"/>
+                      </a:endParaRPr>
+                    </a:p>
+                  </a:txBody>
+                  <a:tcPr marL="91440" marR="91440" marT="45720" marB="45720" anchor="ctr">
+                    <a:lnL w="0" cap="flat" cmpd="sng" algn="ctr">
+                      <a:noFill/>
+                    </a:lnL>
+                    <a:lnR w="0" cap="flat" cmpd="sng" algn="ctr">
+                      <a:noFill/>
+                    </a:lnR>
+                    <a:lnT w="6350" cap="flat" cmpd="sng" algn="ctr">
+                      <a:solidFill>
+                        <a:srgbClr val="E2E8F0"/>
+                      </a:solidFill>
+                      <a:prstDash val="solid"/>
+                      <a:round/>
+                      <a:headEnd type="none" w="med" len="med"/>
+                      <a:tailEnd type="none" w="med" len="med"/>
+                    </a:lnT>
+                    <a:lnB w="0" cap="flat" cmpd="sng" algn="ctr">
+                      <a:noFill/>
+                    </a:lnB>
+                  </a:tcPr>
+                </a:tc>
+                <a:tc>
+                  <a:txBody>
+                    <a:bodyPr/>
+                    <a:lstStyle/>
+                    <a:p>
+                      <a:pPr algn="l" indent="0" marL="0">
+                        <a:buNone/>
+                      </a:pPr>
+                      <a:r>
+                        <a:rPr lang="en-US" sz="1300" dirty="0">
+                          <a:solidFill>
+                            <a:srgbClr val="0F172A"/>
+                          </a:solidFill>
+                          <a:latin typeface="Calibri" pitchFamily="34" charset="0"/>
+                          <a:ea typeface="Calibri" pitchFamily="34" charset="-122"/>
+                          <a:cs typeface="Calibri" pitchFamily="34" charset="-120"/>
+                        </a:rPr>
+                        <a:t>curl -X PATCH .../notes/2 -d JSON</a:t>
+                      </a:r>
+                      <a:endParaRPr lang="en-US" sz="1300" dirty="0">
+                        <a:latin typeface="Calibri" charset="0"/>
+                        <a:ea typeface="Calibri" charset="0"/>
+                        <a:cs typeface="Calibri" charset="0"/>
+                      </a:endParaRPr>
+                    </a:p>
+                  </a:txBody>
+                  <a:tcPr marL="91440" marR="91440" marT="45720" marB="45720" anchor="ctr">
+                    <a:lnL w="0" cap="flat" cmpd="sng" algn="ctr">
+                      <a:noFill/>
+                    </a:lnL>
+                    <a:lnR w="0" cap="flat" cmpd="sng" algn="ctr">
+                      <a:noFill/>
+                    </a:lnR>
+                    <a:lnT w="6350" cap="flat" cmpd="sng" algn="ctr">
+                      <a:solidFill>
+                        <a:srgbClr val="E2E8F0"/>
+                      </a:solidFill>
+                      <a:prstDash val="solid"/>
+                      <a:round/>
+                      <a:headEnd type="none" w="med" len="med"/>
+                      <a:tailEnd type="none" w="med" len="med"/>
+                    </a:lnT>
+                    <a:lnB w="0" cap="flat" cmpd="sng" algn="ctr">
+                      <a:noFill/>
+                    </a:lnB>
+                  </a:tcPr>
+                </a:tc>
+                <a:tc>
+                  <a:txBody>
+                    <a:bodyPr/>
+                    <a:lstStyle/>
+                    <a:p>
+                      <a:pPr algn="l" indent="0" marL="0">
+                        <a:buNone/>
+                      </a:pPr>
+                      <a:r>
+                        <a:rPr lang="en-US" sz="1300" dirty="0">
+                          <a:solidFill>
+                            <a:srgbClr val="0F172A"/>
+                          </a:solidFill>
+                          <a:latin typeface="Calibri" pitchFamily="34" charset="0"/>
+                          <a:ea typeface="Calibri" pitchFamily="34" charset="-122"/>
+                          <a:cs typeface="Calibri" pitchFamily="34" charset="-120"/>
+                        </a:rPr>
+                        <a:t>200, one field changed</a:t>
+                      </a:r>
+                      <a:endParaRPr lang="en-US" sz="1300" dirty="0">
+                        <a:latin typeface="Calibri" charset="0"/>
+                        <a:ea typeface="Calibri" charset="0"/>
+                        <a:cs typeface="Calibri" charset="0"/>
+                      </a:endParaRPr>
+                    </a:p>
+                  </a:txBody>
+                  <a:tcPr marL="91440" marR="91440" marT="45720" marB="45720" anchor="ctr">
+                    <a:lnL w="0" cap="flat" cmpd="sng" algn="ctr">
+                      <a:noFill/>
+                    </a:lnL>
+                    <a:lnR w="0" cap="flat" cmpd="sng" algn="ctr">
+                      <a:noFill/>
+                    </a:lnR>
+                    <a:lnT w="6350" cap="flat" cmpd="sng" algn="ctr">
+                      <a:solidFill>
+                        <a:srgbClr val="E2E8F0"/>
+                      </a:solidFill>
+                      <a:prstDash val="solid"/>
+                      <a:round/>
+                      <a:headEnd type="none" w="med" len="med"/>
+                      <a:tailEnd type="none" w="med" len="med"/>
+                    </a:lnT>
+                    <a:lnB w="0" cap="flat" cmpd="sng" algn="ctr">
+                      <a:noFill/>
+                    </a:lnB>
+                  </a:tcPr>
+                </a:tc>
+              </a:tr>
+              <a:tr h="0">
+                <a:tc>
+                  <a:txBody>
+                    <a:bodyPr/>
+                    <a:lstStyle/>
+                    <a:p>
+                      <a:pPr algn="l" indent="0" marL="0">
+                        <a:buNone/>
+                      </a:pPr>
+                      <a:r>
+                        <a:rPr lang="en-US" sz="1300" dirty="0">
+                          <a:solidFill>
+                            <a:srgbClr val="0F172A"/>
+                          </a:solidFill>
+                          <a:latin typeface="Calibri" pitchFamily="34" charset="0"/>
+                          <a:ea typeface="Calibri" pitchFamily="34" charset="-122"/>
+                          <a:cs typeface="Calibri" pitchFamily="34" charset="-120"/>
+                        </a:rPr>
+                        <a:t>Delete</a:t>
+                      </a:r>
+                      <a:endParaRPr lang="en-US" sz="1300" dirty="0">
+                        <a:latin typeface="Calibri" charset="0"/>
+                        <a:ea typeface="Calibri" charset="0"/>
+                        <a:cs typeface="Calibri" charset="0"/>
+                      </a:endParaRPr>
+                    </a:p>
+                  </a:txBody>
+                  <a:tcPr marL="91440" marR="91440" marT="45720" marB="45720" anchor="ctr">
+                    <a:lnL w="0" cap="flat" cmpd="sng" algn="ctr">
+                      <a:noFill/>
+                    </a:lnL>
+                    <a:lnR w="0" cap="flat" cmpd="sng" algn="ctr">
+                      <a:noFill/>
+                    </a:lnR>
+                    <a:lnT w="6350" cap="flat" cmpd="sng" algn="ctr">
+                      <a:solidFill>
+                        <a:srgbClr val="E2E8F0"/>
+                      </a:solidFill>
+                      <a:prstDash val="solid"/>
+                      <a:round/>
+                      <a:headEnd type="none" w="med" len="med"/>
+                      <a:tailEnd type="none" w="med" len="med"/>
+                    </a:lnT>
+                    <a:lnB w="0" cap="flat" cmpd="sng" algn="ctr">
+                      <a:noFill/>
+                    </a:lnB>
+                  </a:tcPr>
+                </a:tc>
+                <a:tc>
+                  <a:txBody>
+                    <a:bodyPr/>
+                    <a:lstStyle/>
+                    <a:p>
+                      <a:pPr algn="l" indent="0" marL="0">
+                        <a:buNone/>
+                      </a:pPr>
+                      <a:r>
+                        <a:rPr lang="en-US" sz="1300" dirty="0">
+                          <a:solidFill>
+                            <a:srgbClr val="0F172A"/>
+                          </a:solidFill>
+                          <a:latin typeface="Calibri" pitchFamily="34" charset="0"/>
+                          <a:ea typeface="Calibri" pitchFamily="34" charset="-122"/>
+                          <a:cs typeface="Calibri" pitchFamily="34" charset="-120"/>
+                        </a:rPr>
+                        <a:t>curl -X DELETE .../notes/1</a:t>
+                      </a:r>
+                      <a:endParaRPr lang="en-US" sz="1300" dirty="0">
+                        <a:latin typeface="Calibri" charset="0"/>
+                        <a:ea typeface="Calibri" charset="0"/>
+                        <a:cs typeface="Calibri" charset="0"/>
+                      </a:endParaRPr>
+                    </a:p>
+                  </a:txBody>
+                  <a:tcPr marL="91440" marR="91440" marT="45720" marB="45720" anchor="ctr">
+                    <a:lnL w="0" cap="flat" cmpd="sng" algn="ctr">
+                      <a:noFill/>
+                    </a:lnL>
+                    <a:lnR w="0" cap="flat" cmpd="sng" algn="ctr">
+                      <a:noFill/>
+                    </a:lnR>
+                    <a:lnT w="6350" cap="flat" cmpd="sng" algn="ctr">
+                      <a:solidFill>
+                        <a:srgbClr val="E2E8F0"/>
+                      </a:solidFill>
+                      <a:prstDash val="solid"/>
+                      <a:round/>
+                      <a:headEnd type="none" w="med" len="med"/>
+                      <a:tailEnd type="none" w="med" len="med"/>
+                    </a:lnT>
+                    <a:lnB w="0" cap="flat" cmpd="sng" algn="ctr">
+                      <a:noFill/>
+                    </a:lnB>
+                  </a:tcPr>
+                </a:tc>
+                <a:tc>
+                  <a:txBody>
+                    <a:bodyPr/>
+                    <a:lstStyle/>
+                    <a:p>
+                      <a:pPr algn="l" indent="0" marL="0">
+                        <a:buNone/>
+                      </a:pPr>
+                      <a:r>
+                        <a:rPr lang="en-US" sz="1300" dirty="0">
+                          <a:solidFill>
+                            <a:srgbClr val="0F172A"/>
+                          </a:solidFill>
+                          <a:latin typeface="Calibri" pitchFamily="34" charset="0"/>
+                          <a:ea typeface="Calibri" pitchFamily="34" charset="-122"/>
+                          <a:cs typeface="Calibri" pitchFamily="34" charset="-120"/>
+                        </a:rPr>
+                        <a:t>200, note 1 gone</a:t>
                       </a:r>
                       <a:endParaRPr lang="en-US" sz="1300" dirty="0">
                         <a:latin typeface="Calibri" charset="0"/>

</xml_diff>